<commit_message>
Add image-slide support and include slide assets
Implement image-led slides and include module-4 screenshot assets. Added add_image_slide (letterboxed image area, caption, avatar placeholder), enabled italic text in _add_text, and extended Slide dataclass with image/caption and new "image" kind. Updated DECKS to include image slides and adjusted some headlines/subheads. build_deck now accepts an assets_root, validates image paths, and routes image slides to the new renderer. Also added multiple PNG/JPEG assets and updated several PPTX files.
</commit_message>
<xml_diff>
--- a/docs/video-scripts/slides/pptx/module-1/lesson-1-1-what-is-ai.pptx
+++ b/docs/video-scripts/slides/pptx/module-1/lesson-1-1-what-is-ai.pptx
@@ -3170,7 +3170,7 @@
               </a:lnSpc>
             </a:pPr>
             <a:r>
-              <a:rPr sz="1400" b="1">
+              <a:rPr sz="1400" b="1" i="0">
                 <a:solidFill>
                   <a:srgbClr val="2B6E2B"/>
                 </a:solidFill>
@@ -3209,7 +3209,7 @@
               </a:lnSpc>
             </a:pPr>
             <a:r>
-              <a:rPr sz="5400" b="1">
+              <a:rPr sz="5400" b="1" i="0">
                 <a:solidFill>
                   <a:srgbClr val="030303"/>
                 </a:solidFill>
@@ -3248,7 +3248,7 @@
               </a:lnSpc>
             </a:pPr>
             <a:r>
-              <a:rPr sz="2200" b="0">
+              <a:rPr sz="2200" b="0" i="0">
                 <a:solidFill>
                   <a:srgbClr val="272525"/>
                 </a:solidFill>
@@ -3287,7 +3287,7 @@
               </a:lnSpc>
             </a:pPr>
             <a:r>
-              <a:rPr sz="1100" b="1">
+              <a:rPr sz="1100" b="1" i="0">
                 <a:solidFill>
                   <a:srgbClr val="2B6E2B"/>
                 </a:solidFill>
@@ -3352,7 +3352,7 @@
               </a:lnSpc>
             </a:pPr>
             <a:r>
-              <a:rPr sz="1200" b="1">
+              <a:rPr sz="1200" b="1" i="0">
                 <a:solidFill>
                   <a:srgbClr val="2B6E2B"/>
                 </a:solidFill>
@@ -3391,7 +3391,7 @@
               </a:lnSpc>
             </a:pPr>
             <a:r>
-              <a:rPr sz="4200" b="1">
+              <a:rPr sz="4200" b="1" i="0">
                 <a:solidFill>
                   <a:srgbClr val="030303"/>
                 </a:solidFill>
@@ -3474,7 +3474,7 @@
               </a:lnSpc>
             </a:pPr>
             <a:r>
-              <a:rPr sz="2200" b="0">
+              <a:rPr sz="2200" b="0" i="0">
                 <a:solidFill>
                   <a:srgbClr val="272525"/>
                 </a:solidFill>
@@ -3490,7 +3490,7 @@
               </a:lnSpc>
             </a:pPr>
             <a:r>
-              <a:rPr sz="2200" b="0">
+              <a:rPr sz="2200" b="0" i="0">
                 <a:solidFill>
                   <a:srgbClr val="272525"/>
                 </a:solidFill>
@@ -3506,7 +3506,7 @@
               </a:lnSpc>
             </a:pPr>
             <a:r>
-              <a:rPr sz="2200" b="0">
+              <a:rPr sz="2200" b="0" i="0">
                 <a:solidFill>
                   <a:srgbClr val="272525"/>
                 </a:solidFill>
@@ -3571,7 +3571,7 @@
               </a:lnSpc>
             </a:pPr>
             <a:r>
-              <a:rPr sz="1200" b="1">
+              <a:rPr sz="1200" b="1" i="0">
                 <a:solidFill>
                   <a:srgbClr val="2B6E2B"/>
                 </a:solidFill>
@@ -3610,7 +3610,7 @@
               </a:lnSpc>
             </a:pPr>
             <a:r>
-              <a:rPr sz="4200" b="1">
+              <a:rPr sz="4200" b="1" i="0">
                 <a:solidFill>
                   <a:srgbClr val="030303"/>
                 </a:solidFill>
@@ -3737,7 +3737,7 @@
               </a:lnSpc>
             </a:pPr>
             <a:r>
-              <a:rPr sz="2600" b="1">
+              <a:rPr sz="2600" b="1" i="0">
                 <a:solidFill>
                   <a:srgbClr val="030303"/>
                 </a:solidFill>
@@ -3753,7 +3753,7 @@
               </a:lnSpc>
             </a:pPr>
             <a:r>
-              <a:rPr sz="2600" b="1">
+              <a:rPr sz="2600" b="1" i="0">
                 <a:solidFill>
                   <a:srgbClr val="030303"/>
                 </a:solidFill>

</xml_diff>

<commit_message>
Add slide images and fix lesson text
Add exported JPEG slides for module-1 and module-6, and update related PPTX binaries. Also adjust lesson copy: clean up formatting in module-1 ground-rules section and change the exercise prompt in module-6 to reference "company HR procedures." Note: several Office temp (~$...) files were added alongside the slide assets.
</commit_message>
<xml_diff>
--- a/docs/video-scripts/slides/pptx/module-1/lesson-1-1-what-is-ai.pptx
+++ b/docs/video-scripts/slides/pptx/module-1/lesson-1-1-what-is-ai.pptx
@@ -5,11 +5,11 @@
     <p:sldMasterId id="2147483648" r:id="rId1"/>
   </p:sldMasterIdLst>
   <p:sldIdLst>
-    <p:sldId id="256" r:id="rId7"/>
-    <p:sldId id="257" r:id="rId8"/>
-    <p:sldId id="258" r:id="rId9"/>
+    <p:sldId id="256" r:id="rId2"/>
+    <p:sldId id="257" r:id="rId3"/>
+    <p:sldId id="258" r:id="rId4"/>
   </p:sldIdLst>
-  <p:sldSz cx="14630400" cy="8229600" type="screen4x3"/>
+  <p:sldSz cx="14630400" cy="8229600"/>
   <p:notesSz cx="6858000" cy="9144000"/>
   <p:defaultTextStyle>
     <a:defPPr>
@@ -106,6 +106,22 @@
       </a:defRPr>
     </a:lvl9pPr>
   </p:defaultTextStyle>
+  <p:extLst>
+    <p:ext uri="{EFAFB233-063F-42B5-8137-9DF3F51BA10A}">
+      <p15:sldGuideLst xmlns:p15="http://schemas.microsoft.com/office/powerpoint/2012/main">
+        <p15:guide id="1" orient="horz" pos="2160">
+          <p15:clr>
+            <a:srgbClr val="A4A3A4"/>
+          </p15:clr>
+        </p15:guide>
+        <p15:guide id="2" pos="2880">
+          <p15:clr>
+            <a:srgbClr val="A4A3A4"/>
+          </p15:clr>
+        </p15:guide>
+      </p15:sldGuideLst>
+    </p:ext>
+  </p:extLst>
 </p:presentation>
 </file>
 
@@ -147,10 +163,9 @@
           <a:lstStyle/>
           <a:p>
             <a:r>
-              <a:rPr lang="en-US" smtClean="0"/>
+              <a:rPr lang="en-US"/>
               <a:t>Click to edit Master title style</a:t>
             </a:r>
-            <a:endParaRPr lang="en-US"/>
           </a:p>
         </p:txBody>
       </p:sp>
@@ -266,10 +281,9 @@
           </a:lstStyle>
           <a:p>
             <a:r>
-              <a:rPr lang="en-US" smtClean="0"/>
+              <a:rPr lang="en-US"/>
               <a:t>Click to edit Master subtitle style</a:t>
             </a:r>
-            <a:endParaRPr lang="en-US"/>
           </a:p>
         </p:txBody>
       </p:sp>
@@ -290,7 +304,7 @@
           <a:p>
             <a:fld id="{5BCAD085-E8A6-8845-BD4E-CB4CCA059FC4}" type="datetimeFigureOut">
               <a:rPr lang="en-US" smtClean="0"/>
-              <a:t>1/27/13</a:t>
+              <a:t>5/6/26</a:t>
             </a:fld>
             <a:endParaRPr lang="en-US"/>
           </a:p>
@@ -384,10 +398,9 @@
           <a:lstStyle/>
           <a:p>
             <a:r>
-              <a:rPr lang="en-US" smtClean="0"/>
+              <a:rPr lang="en-US"/>
               <a:t>Click to edit Master title style</a:t>
             </a:r>
-            <a:endParaRPr lang="en-US"/>
           </a:p>
         </p:txBody>
       </p:sp>
@@ -408,38 +421,37 @@
           <a:p>
             <a:pPr lvl="0"/>
             <a:r>
-              <a:rPr lang="en-US" smtClean="0"/>
+              <a:rPr lang="en-US"/>
               <a:t>Click to edit Master text styles</a:t>
             </a:r>
           </a:p>
           <a:p>
             <a:pPr lvl="1"/>
             <a:r>
-              <a:rPr lang="en-US" smtClean="0"/>
+              <a:rPr lang="en-US"/>
               <a:t>Second level</a:t>
             </a:r>
           </a:p>
           <a:p>
             <a:pPr lvl="2"/>
             <a:r>
-              <a:rPr lang="en-US" smtClean="0"/>
+              <a:rPr lang="en-US"/>
               <a:t>Third level</a:t>
             </a:r>
           </a:p>
           <a:p>
             <a:pPr lvl="3"/>
             <a:r>
-              <a:rPr lang="en-US" smtClean="0"/>
+              <a:rPr lang="en-US"/>
               <a:t>Fourth level</a:t>
             </a:r>
           </a:p>
           <a:p>
             <a:pPr lvl="4"/>
             <a:r>
-              <a:rPr lang="en-US" smtClean="0"/>
+              <a:rPr lang="en-US"/>
               <a:t>Fifth level</a:t>
             </a:r>
-            <a:endParaRPr lang="en-US"/>
           </a:p>
         </p:txBody>
       </p:sp>
@@ -460,7 +472,7 @@
           <a:p>
             <a:fld id="{5BCAD085-E8A6-8845-BD4E-CB4CCA059FC4}" type="datetimeFigureOut">
               <a:rPr lang="en-US" smtClean="0"/>
-              <a:t>1/27/13</a:t>
+              <a:t>5/6/26</a:t>
             </a:fld>
             <a:endParaRPr lang="en-US"/>
           </a:p>
@@ -559,10 +571,9 @@
           <a:lstStyle/>
           <a:p>
             <a:r>
-              <a:rPr lang="en-US" smtClean="0"/>
+              <a:rPr lang="en-US"/>
               <a:t>Click to edit Master title style</a:t>
             </a:r>
-            <a:endParaRPr lang="en-US"/>
           </a:p>
         </p:txBody>
       </p:sp>
@@ -588,38 +599,37 @@
           <a:p>
             <a:pPr lvl="0"/>
             <a:r>
-              <a:rPr lang="en-US" smtClean="0"/>
+              <a:rPr lang="en-US"/>
               <a:t>Click to edit Master text styles</a:t>
             </a:r>
           </a:p>
           <a:p>
             <a:pPr lvl="1"/>
             <a:r>
-              <a:rPr lang="en-US" smtClean="0"/>
+              <a:rPr lang="en-US"/>
               <a:t>Second level</a:t>
             </a:r>
           </a:p>
           <a:p>
             <a:pPr lvl="2"/>
             <a:r>
-              <a:rPr lang="en-US" smtClean="0"/>
+              <a:rPr lang="en-US"/>
               <a:t>Third level</a:t>
             </a:r>
           </a:p>
           <a:p>
             <a:pPr lvl="3"/>
             <a:r>
-              <a:rPr lang="en-US" smtClean="0"/>
+              <a:rPr lang="en-US"/>
               <a:t>Fourth level</a:t>
             </a:r>
           </a:p>
           <a:p>
             <a:pPr lvl="4"/>
             <a:r>
-              <a:rPr lang="en-US" smtClean="0"/>
+              <a:rPr lang="en-US"/>
               <a:t>Fifth level</a:t>
             </a:r>
-            <a:endParaRPr lang="en-US"/>
           </a:p>
         </p:txBody>
       </p:sp>
@@ -640,7 +650,7 @@
           <a:p>
             <a:fld id="{5BCAD085-E8A6-8845-BD4E-CB4CCA059FC4}" type="datetimeFigureOut">
               <a:rPr lang="en-US" smtClean="0"/>
-              <a:t>1/27/13</a:t>
+              <a:t>5/6/26</a:t>
             </a:fld>
             <a:endParaRPr lang="en-US"/>
           </a:p>
@@ -734,10 +744,9 @@
           <a:lstStyle/>
           <a:p>
             <a:r>
-              <a:rPr lang="en-US" smtClean="0"/>
+              <a:rPr lang="en-US"/>
               <a:t>Click to edit Master title style</a:t>
             </a:r>
-            <a:endParaRPr lang="en-US"/>
           </a:p>
         </p:txBody>
       </p:sp>
@@ -758,38 +767,37 @@
           <a:p>
             <a:pPr lvl="0"/>
             <a:r>
-              <a:rPr lang="en-US" smtClean="0"/>
+              <a:rPr lang="en-US"/>
               <a:t>Click to edit Master text styles</a:t>
             </a:r>
           </a:p>
           <a:p>
             <a:pPr lvl="1"/>
             <a:r>
-              <a:rPr lang="en-US" smtClean="0"/>
+              <a:rPr lang="en-US"/>
               <a:t>Second level</a:t>
             </a:r>
           </a:p>
           <a:p>
             <a:pPr lvl="2"/>
             <a:r>
-              <a:rPr lang="en-US" smtClean="0"/>
+              <a:rPr lang="en-US"/>
               <a:t>Third level</a:t>
             </a:r>
           </a:p>
           <a:p>
             <a:pPr lvl="3"/>
             <a:r>
-              <a:rPr lang="en-US" smtClean="0"/>
+              <a:rPr lang="en-US"/>
               <a:t>Fourth level</a:t>
             </a:r>
           </a:p>
           <a:p>
             <a:pPr lvl="4"/>
             <a:r>
-              <a:rPr lang="en-US" smtClean="0"/>
+              <a:rPr lang="en-US"/>
               <a:t>Fifth level</a:t>
             </a:r>
-            <a:endParaRPr lang="en-US"/>
           </a:p>
         </p:txBody>
       </p:sp>
@@ -810,7 +818,7 @@
           <a:p>
             <a:fld id="{5BCAD085-E8A6-8845-BD4E-CB4CCA059FC4}" type="datetimeFigureOut">
               <a:rPr lang="en-US" smtClean="0"/>
-              <a:t>1/27/13</a:t>
+              <a:t>5/6/26</a:t>
             </a:fld>
             <a:endParaRPr lang="en-US"/>
           </a:p>
@@ -913,10 +921,9 @@
           </a:lstStyle>
           <a:p>
             <a:r>
-              <a:rPr lang="en-US" smtClean="0"/>
+              <a:rPr lang="en-US"/>
               <a:t>Click to edit Master title style</a:t>
             </a:r>
-            <a:endParaRPr lang="en-US"/>
           </a:p>
         </p:txBody>
       </p:sp>
@@ -1033,7 +1040,7 @@
           <a:p>
             <a:pPr lvl="0"/>
             <a:r>
-              <a:rPr lang="en-US" smtClean="0"/>
+              <a:rPr lang="en-US"/>
               <a:t>Click to edit Master text styles</a:t>
             </a:r>
           </a:p>
@@ -1056,7 +1063,7 @@
           <a:p>
             <a:fld id="{5BCAD085-E8A6-8845-BD4E-CB4CCA059FC4}" type="datetimeFigureOut">
               <a:rPr lang="en-US" smtClean="0"/>
-              <a:t>1/27/13</a:t>
+              <a:t>5/6/26</a:t>
             </a:fld>
             <a:endParaRPr lang="en-US"/>
           </a:p>
@@ -1150,10 +1157,9 @@
           <a:lstStyle/>
           <a:p>
             <a:r>
-              <a:rPr lang="en-US" smtClean="0"/>
+              <a:rPr lang="en-US"/>
               <a:t>Click to edit Master title style</a:t>
             </a:r>
-            <a:endParaRPr lang="en-US"/>
           </a:p>
         </p:txBody>
       </p:sp>
@@ -1207,38 +1213,37 @@
           <a:p>
             <a:pPr lvl="0"/>
             <a:r>
-              <a:rPr lang="en-US" smtClean="0"/>
+              <a:rPr lang="en-US"/>
               <a:t>Click to edit Master text styles</a:t>
             </a:r>
           </a:p>
           <a:p>
             <a:pPr lvl="1"/>
             <a:r>
-              <a:rPr lang="en-US" smtClean="0"/>
+              <a:rPr lang="en-US"/>
               <a:t>Second level</a:t>
             </a:r>
           </a:p>
           <a:p>
             <a:pPr lvl="2"/>
             <a:r>
-              <a:rPr lang="en-US" smtClean="0"/>
+              <a:rPr lang="en-US"/>
               <a:t>Third level</a:t>
             </a:r>
           </a:p>
           <a:p>
             <a:pPr lvl="3"/>
             <a:r>
-              <a:rPr lang="en-US" smtClean="0"/>
+              <a:rPr lang="en-US"/>
               <a:t>Fourth level</a:t>
             </a:r>
           </a:p>
           <a:p>
             <a:pPr lvl="4"/>
             <a:r>
-              <a:rPr lang="en-US" smtClean="0"/>
+              <a:rPr lang="en-US"/>
               <a:t>Fifth level</a:t>
             </a:r>
-            <a:endParaRPr lang="en-US"/>
           </a:p>
         </p:txBody>
       </p:sp>
@@ -1292,38 +1297,37 @@
           <a:p>
             <a:pPr lvl="0"/>
             <a:r>
-              <a:rPr lang="en-US" smtClean="0"/>
+              <a:rPr lang="en-US"/>
               <a:t>Click to edit Master text styles</a:t>
             </a:r>
           </a:p>
           <a:p>
             <a:pPr lvl="1"/>
             <a:r>
-              <a:rPr lang="en-US" smtClean="0"/>
+              <a:rPr lang="en-US"/>
               <a:t>Second level</a:t>
             </a:r>
           </a:p>
           <a:p>
             <a:pPr lvl="2"/>
             <a:r>
-              <a:rPr lang="en-US" smtClean="0"/>
+              <a:rPr lang="en-US"/>
               <a:t>Third level</a:t>
             </a:r>
           </a:p>
           <a:p>
             <a:pPr lvl="3"/>
             <a:r>
-              <a:rPr lang="en-US" smtClean="0"/>
+              <a:rPr lang="en-US"/>
               <a:t>Fourth level</a:t>
             </a:r>
           </a:p>
           <a:p>
             <a:pPr lvl="4"/>
             <a:r>
-              <a:rPr lang="en-US" smtClean="0"/>
+              <a:rPr lang="en-US"/>
               <a:t>Fifth level</a:t>
             </a:r>
-            <a:endParaRPr lang="en-US"/>
           </a:p>
         </p:txBody>
       </p:sp>
@@ -1344,7 +1348,7 @@
           <a:p>
             <a:fld id="{5BCAD085-E8A6-8845-BD4E-CB4CCA059FC4}" type="datetimeFigureOut">
               <a:rPr lang="en-US" smtClean="0"/>
-              <a:t>1/27/13</a:t>
+              <a:t>5/6/26</a:t>
             </a:fld>
             <a:endParaRPr lang="en-US"/>
           </a:p>
@@ -1442,10 +1446,9 @@
           </a:lstStyle>
           <a:p>
             <a:r>
-              <a:rPr lang="en-US" smtClean="0"/>
+              <a:rPr lang="en-US"/>
               <a:t>Click to edit Master title style</a:t>
             </a:r>
-            <a:endParaRPr lang="en-US"/>
           </a:p>
         </p:txBody>
       </p:sp>
@@ -1508,7 +1511,7 @@
           <a:p>
             <a:pPr lvl="0"/>
             <a:r>
-              <a:rPr lang="en-US" smtClean="0"/>
+              <a:rPr lang="en-US"/>
               <a:t>Click to edit Master text styles</a:t>
             </a:r>
           </a:p>
@@ -1564,38 +1567,37 @@
           <a:p>
             <a:pPr lvl="0"/>
             <a:r>
-              <a:rPr lang="en-US" smtClean="0"/>
+              <a:rPr lang="en-US"/>
               <a:t>Click to edit Master text styles</a:t>
             </a:r>
           </a:p>
           <a:p>
             <a:pPr lvl="1"/>
             <a:r>
-              <a:rPr lang="en-US" smtClean="0"/>
+              <a:rPr lang="en-US"/>
               <a:t>Second level</a:t>
             </a:r>
           </a:p>
           <a:p>
             <a:pPr lvl="2"/>
             <a:r>
-              <a:rPr lang="en-US" smtClean="0"/>
+              <a:rPr lang="en-US"/>
               <a:t>Third level</a:t>
             </a:r>
           </a:p>
           <a:p>
             <a:pPr lvl="3"/>
             <a:r>
-              <a:rPr lang="en-US" smtClean="0"/>
+              <a:rPr lang="en-US"/>
               <a:t>Fourth level</a:t>
             </a:r>
           </a:p>
           <a:p>
             <a:pPr lvl="4"/>
             <a:r>
-              <a:rPr lang="en-US" smtClean="0"/>
+              <a:rPr lang="en-US"/>
               <a:t>Fifth level</a:t>
             </a:r>
-            <a:endParaRPr lang="en-US"/>
           </a:p>
         </p:txBody>
       </p:sp>
@@ -1658,7 +1660,7 @@
           <a:p>
             <a:pPr lvl="0"/>
             <a:r>
-              <a:rPr lang="en-US" smtClean="0"/>
+              <a:rPr lang="en-US"/>
               <a:t>Click to edit Master text styles</a:t>
             </a:r>
           </a:p>
@@ -1714,38 +1716,37 @@
           <a:p>
             <a:pPr lvl="0"/>
             <a:r>
-              <a:rPr lang="en-US" smtClean="0"/>
+              <a:rPr lang="en-US"/>
               <a:t>Click to edit Master text styles</a:t>
             </a:r>
           </a:p>
           <a:p>
             <a:pPr lvl="1"/>
             <a:r>
-              <a:rPr lang="en-US" smtClean="0"/>
+              <a:rPr lang="en-US"/>
               <a:t>Second level</a:t>
             </a:r>
           </a:p>
           <a:p>
             <a:pPr lvl="2"/>
             <a:r>
-              <a:rPr lang="en-US" smtClean="0"/>
+              <a:rPr lang="en-US"/>
               <a:t>Third level</a:t>
             </a:r>
           </a:p>
           <a:p>
             <a:pPr lvl="3"/>
             <a:r>
-              <a:rPr lang="en-US" smtClean="0"/>
+              <a:rPr lang="en-US"/>
               <a:t>Fourth level</a:t>
             </a:r>
           </a:p>
           <a:p>
             <a:pPr lvl="4"/>
             <a:r>
-              <a:rPr lang="en-US" smtClean="0"/>
+              <a:rPr lang="en-US"/>
               <a:t>Fifth level</a:t>
             </a:r>
-            <a:endParaRPr lang="en-US"/>
           </a:p>
         </p:txBody>
       </p:sp>
@@ -1766,7 +1767,7 @@
           <a:p>
             <a:fld id="{5BCAD085-E8A6-8845-BD4E-CB4CCA059FC4}" type="datetimeFigureOut">
               <a:rPr lang="en-US" smtClean="0"/>
-              <a:t>1/27/13</a:t>
+              <a:t>5/6/26</a:t>
             </a:fld>
             <a:endParaRPr lang="en-US"/>
           </a:p>
@@ -1860,10 +1861,9 @@
           <a:lstStyle/>
           <a:p>
             <a:r>
-              <a:rPr lang="en-US" smtClean="0"/>
+              <a:rPr lang="en-US"/>
               <a:t>Click to edit Master title style</a:t>
             </a:r>
-            <a:endParaRPr lang="en-US"/>
           </a:p>
         </p:txBody>
       </p:sp>
@@ -1884,7 +1884,7 @@
           <a:p>
             <a:fld id="{5BCAD085-E8A6-8845-BD4E-CB4CCA059FC4}" type="datetimeFigureOut">
               <a:rPr lang="en-US" smtClean="0"/>
-              <a:t>1/27/13</a:t>
+              <a:t>5/6/26</a:t>
             </a:fld>
             <a:endParaRPr lang="en-US"/>
           </a:p>
@@ -1979,7 +1979,7 @@
           <a:p>
             <a:fld id="{5BCAD085-E8A6-8845-BD4E-CB4CCA059FC4}" type="datetimeFigureOut">
               <a:rPr lang="en-US" smtClean="0"/>
-              <a:t>1/27/13</a:t>
+              <a:t>5/6/26</a:t>
             </a:fld>
             <a:endParaRPr lang="en-US"/>
           </a:p>
@@ -2082,10 +2082,9 @@
           </a:lstStyle>
           <a:p>
             <a:r>
-              <a:rPr lang="en-US" smtClean="0"/>
+              <a:rPr lang="en-US"/>
               <a:t>Click to edit Master title style</a:t>
             </a:r>
-            <a:endParaRPr lang="en-US"/>
           </a:p>
         </p:txBody>
       </p:sp>
@@ -2139,38 +2138,37 @@
           <a:p>
             <a:pPr lvl="0"/>
             <a:r>
-              <a:rPr lang="en-US" smtClean="0"/>
+              <a:rPr lang="en-US"/>
               <a:t>Click to edit Master text styles</a:t>
             </a:r>
           </a:p>
           <a:p>
             <a:pPr lvl="1"/>
             <a:r>
-              <a:rPr lang="en-US" smtClean="0"/>
+              <a:rPr lang="en-US"/>
               <a:t>Second level</a:t>
             </a:r>
           </a:p>
           <a:p>
             <a:pPr lvl="2"/>
             <a:r>
-              <a:rPr lang="en-US" smtClean="0"/>
+              <a:rPr lang="en-US"/>
               <a:t>Third level</a:t>
             </a:r>
           </a:p>
           <a:p>
             <a:pPr lvl="3"/>
             <a:r>
-              <a:rPr lang="en-US" smtClean="0"/>
+              <a:rPr lang="en-US"/>
               <a:t>Fourth level</a:t>
             </a:r>
           </a:p>
           <a:p>
             <a:pPr lvl="4"/>
             <a:r>
-              <a:rPr lang="en-US" smtClean="0"/>
+              <a:rPr lang="en-US"/>
               <a:t>Fifth level</a:t>
             </a:r>
-            <a:endParaRPr lang="en-US"/>
           </a:p>
         </p:txBody>
       </p:sp>
@@ -2233,7 +2231,7 @@
           <a:p>
             <a:pPr lvl="0"/>
             <a:r>
-              <a:rPr lang="en-US" smtClean="0"/>
+              <a:rPr lang="en-US"/>
               <a:t>Click to edit Master text styles</a:t>
             </a:r>
           </a:p>
@@ -2256,7 +2254,7 @@
           <a:p>
             <a:fld id="{5BCAD085-E8A6-8845-BD4E-CB4CCA059FC4}" type="datetimeFigureOut">
               <a:rPr lang="en-US" smtClean="0"/>
-              <a:t>1/27/13</a:t>
+              <a:t>5/6/26</a:t>
             </a:fld>
             <a:endParaRPr lang="en-US"/>
           </a:p>
@@ -2359,10 +2357,9 @@
           </a:lstStyle>
           <a:p>
             <a:r>
-              <a:rPr lang="en-US" smtClean="0"/>
+              <a:rPr lang="en-US"/>
               <a:t>Click to edit Master title style</a:t>
             </a:r>
-            <a:endParaRPr lang="en-US"/>
           </a:p>
         </p:txBody>
       </p:sp>
@@ -2486,7 +2483,7 @@
           <a:p>
             <a:pPr lvl="0"/>
             <a:r>
-              <a:rPr lang="en-US" smtClean="0"/>
+              <a:rPr lang="en-US"/>
               <a:t>Click to edit Master text styles</a:t>
             </a:r>
           </a:p>
@@ -2509,7 +2506,7 @@
           <a:p>
             <a:fld id="{5BCAD085-E8A6-8845-BD4E-CB4CCA059FC4}" type="datetimeFigureOut">
               <a:rPr lang="en-US" smtClean="0"/>
-              <a:t>1/27/13</a:t>
+              <a:t>5/6/26</a:t>
             </a:fld>
             <a:endParaRPr lang="en-US"/>
           </a:p>
@@ -2618,10 +2615,9 @@
           <a:lstStyle/>
           <a:p>
             <a:r>
-              <a:rPr lang="en-US" smtClean="0"/>
+              <a:rPr lang="en-US"/>
               <a:t>Click to edit Master title style</a:t>
             </a:r>
-            <a:endParaRPr lang="en-US"/>
           </a:p>
         </p:txBody>
       </p:sp>
@@ -2652,38 +2648,37 @@
           <a:p>
             <a:pPr lvl="0"/>
             <a:r>
-              <a:rPr lang="en-US" smtClean="0"/>
+              <a:rPr lang="en-US"/>
               <a:t>Click to edit Master text styles</a:t>
             </a:r>
           </a:p>
           <a:p>
             <a:pPr lvl="1"/>
             <a:r>
-              <a:rPr lang="en-US" smtClean="0"/>
+              <a:rPr lang="en-US"/>
               <a:t>Second level</a:t>
             </a:r>
           </a:p>
           <a:p>
             <a:pPr lvl="2"/>
             <a:r>
-              <a:rPr lang="en-US" smtClean="0"/>
+              <a:rPr lang="en-US"/>
               <a:t>Third level</a:t>
             </a:r>
           </a:p>
           <a:p>
             <a:pPr lvl="3"/>
             <a:r>
-              <a:rPr lang="en-US" smtClean="0"/>
+              <a:rPr lang="en-US"/>
               <a:t>Fourth level</a:t>
             </a:r>
           </a:p>
           <a:p>
             <a:pPr lvl="4"/>
             <a:r>
-              <a:rPr lang="en-US" smtClean="0"/>
+              <a:rPr lang="en-US"/>
               <a:t>Fifth level</a:t>
             </a:r>
-            <a:endParaRPr lang="en-US"/>
           </a:p>
         </p:txBody>
       </p:sp>
@@ -2722,7 +2717,7 @@
           <a:p>
             <a:fld id="{5BCAD085-E8A6-8845-BD4E-CB4CCA059FC4}" type="datetimeFigureOut">
               <a:rPr lang="en-US" smtClean="0"/>
-              <a:t>1/27/13</a:t>
+              <a:t>5/6/26</a:t>
             </a:fld>
             <a:endParaRPr lang="en-US"/>
           </a:p>
@@ -3081,7 +3076,7 @@
 </file>
 
 <file path=ppt/slides/slide1.xml><?xml version="1.0" encoding="utf-8"?>
-<p:sld xmlns:a="http://schemas.openxmlformats.org/drawingml/2006/main" xmlns:p="http://schemas.openxmlformats.org/presentationml/2006/main" xmlns:r="http://schemas.openxmlformats.org/officeDocument/2006/relationships">
+<p:sld xmlns:a="http://schemas.openxmlformats.org/drawingml/2006/main" xmlns:r="http://schemas.openxmlformats.org/officeDocument/2006/relationships" xmlns:p="http://schemas.openxmlformats.org/presentationml/2006/main">
   <p:cSld>
     <p:bg>
       <p:bgPr>
@@ -3097,7 +3092,14 @@
         <p:cNvGrpSpPr/>
         <p:nvPr/>
       </p:nvGrpSpPr>
-      <p:grpSpPr/>
+      <p:grpSpPr>
+        <a:xfrm>
+          <a:off x="0" y="0"/>
+          <a:ext cx="0" cy="0"/>
+          <a:chOff x="0" y="0"/>
+          <a:chExt cx="0" cy="0"/>
+        </a:xfrm>
+      </p:grpSpPr>
       <p:sp>
         <p:nvSpPr>
           <p:cNvPr id="2" name="Rectangle 1"/>
@@ -3139,6 +3141,7 @@
           <a:lstStyle/>
           <a:p>
             <a:pPr algn="ctr"/>
+            <a:endParaRPr/>
           </a:p>
         </p:txBody>
       </p:sp>
@@ -3159,7 +3162,7 @@
           <a:noFill/>
         </p:spPr>
         <p:txBody>
-          <a:bodyPr wrap="square" lIns="0" rIns="0" tIns="0" bIns="0" anchor="t">
+          <a:bodyPr wrap="square" lIns="0" tIns="0" rIns="0" bIns="0" anchor="t">
             <a:spAutoFit/>
           </a:bodyPr>
           <a:lstStyle/>
@@ -3198,7 +3201,7 @@
           <a:noFill/>
         </p:spPr>
         <p:txBody>
-          <a:bodyPr wrap="square" lIns="0" rIns="0" tIns="0" bIns="0" anchor="t">
+          <a:bodyPr wrap="square" lIns="0" tIns="0" rIns="0" bIns="0" anchor="t">
             <a:spAutoFit/>
           </a:bodyPr>
           <a:lstStyle/>
@@ -3237,7 +3240,7 @@
           <a:noFill/>
         </p:spPr>
         <p:txBody>
-          <a:bodyPr wrap="square" lIns="0" rIns="0" tIns="0" bIns="0" anchor="t">
+          <a:bodyPr wrap="square" lIns="0" tIns="0" rIns="0" bIns="0" anchor="t">
             <a:spAutoFit/>
           </a:bodyPr>
           <a:lstStyle/>
@@ -3276,7 +3279,7 @@
           <a:noFill/>
         </p:spPr>
         <p:txBody>
-          <a:bodyPr wrap="square" lIns="0" rIns="0" tIns="0" bIns="0" anchor="t">
+          <a:bodyPr wrap="square" lIns="0" tIns="0" rIns="0" bIns="0" anchor="t">
             <a:spAutoFit/>
           </a:bodyPr>
           <a:lstStyle/>
@@ -3307,7 +3310,7 @@
 </file>
 
 <file path=ppt/slides/slide2.xml><?xml version="1.0" encoding="utf-8"?>
-<p:sld xmlns:a="http://schemas.openxmlformats.org/drawingml/2006/main" xmlns:p="http://schemas.openxmlformats.org/presentationml/2006/main" xmlns:r="http://schemas.openxmlformats.org/officeDocument/2006/relationships">
+<p:sld xmlns:a="http://schemas.openxmlformats.org/drawingml/2006/main" xmlns:r="http://schemas.openxmlformats.org/officeDocument/2006/relationships" xmlns:p="http://schemas.openxmlformats.org/presentationml/2006/main">
   <p:cSld>
     <p:bg>
       <p:bgPr>
@@ -3323,7 +3326,14 @@
         <p:cNvGrpSpPr/>
         <p:nvPr/>
       </p:nvGrpSpPr>
-      <p:grpSpPr/>
+      <p:grpSpPr>
+        <a:xfrm>
+          <a:off x="0" y="0"/>
+          <a:ext cx="0" cy="0"/>
+          <a:chOff x="0" y="0"/>
+          <a:chExt cx="0" cy="0"/>
+        </a:xfrm>
+      </p:grpSpPr>
       <p:sp>
         <p:nvSpPr>
           <p:cNvPr id="2" name="TextBox 1"/>
@@ -3341,7 +3351,7 @@
           <a:noFill/>
         </p:spPr>
         <p:txBody>
-          <a:bodyPr wrap="square" lIns="0" rIns="0" tIns="0" bIns="0" anchor="t">
+          <a:bodyPr wrap="square" lIns="0" tIns="0" rIns="0" bIns="0" anchor="t">
             <a:spAutoFit/>
           </a:bodyPr>
           <a:lstStyle/>
@@ -3380,7 +3390,7 @@
           <a:noFill/>
         </p:spPr>
         <p:txBody>
-          <a:bodyPr wrap="square" lIns="0" rIns="0" tIns="0" bIns="0" anchor="t">
+          <a:bodyPr wrap="square" lIns="0" tIns="0" rIns="0" bIns="0" anchor="t">
             <a:spAutoFit/>
           </a:bodyPr>
           <a:lstStyle/>
@@ -3443,6 +3453,7 @@
           <a:lstStyle/>
           <a:p>
             <a:pPr algn="ctr"/>
+            <a:endParaRPr/>
           </a:p>
         </p:txBody>
       </p:sp>
@@ -3463,7 +3474,7 @@
           <a:noFill/>
         </p:spPr>
         <p:txBody>
-          <a:bodyPr wrap="square" lIns="0" rIns="0" tIns="0" bIns="0" anchor="t">
+          <a:bodyPr wrap="square" lIns="0" tIns="0" rIns="0" bIns="0" anchor="t">
             <a:spAutoFit/>
           </a:bodyPr>
           <a:lstStyle/>
@@ -3526,7 +3537,7 @@
 </file>
 
 <file path=ppt/slides/slide3.xml><?xml version="1.0" encoding="utf-8"?>
-<p:sld xmlns:a="http://schemas.openxmlformats.org/drawingml/2006/main" xmlns:p="http://schemas.openxmlformats.org/presentationml/2006/main" xmlns:r="http://schemas.openxmlformats.org/officeDocument/2006/relationships">
+<p:sld xmlns:a="http://schemas.openxmlformats.org/drawingml/2006/main" xmlns:r="http://schemas.openxmlformats.org/officeDocument/2006/relationships" xmlns:p="http://schemas.openxmlformats.org/presentationml/2006/main">
   <p:cSld>
     <p:bg>
       <p:bgPr>
@@ -3542,7 +3553,14 @@
         <p:cNvGrpSpPr/>
         <p:nvPr/>
       </p:nvGrpSpPr>
-      <p:grpSpPr/>
+      <p:grpSpPr>
+        <a:xfrm>
+          <a:off x="0" y="0"/>
+          <a:ext cx="0" cy="0"/>
+          <a:chOff x="0" y="0"/>
+          <a:chExt cx="0" cy="0"/>
+        </a:xfrm>
+      </p:grpSpPr>
       <p:sp>
         <p:nvSpPr>
           <p:cNvPr id="2" name="TextBox 1"/>
@@ -3560,7 +3578,7 @@
           <a:noFill/>
         </p:spPr>
         <p:txBody>
-          <a:bodyPr wrap="square" lIns="0" rIns="0" tIns="0" bIns="0" anchor="t">
+          <a:bodyPr wrap="square" lIns="0" tIns="0" rIns="0" bIns="0" anchor="t">
             <a:spAutoFit/>
           </a:bodyPr>
           <a:lstStyle/>
@@ -3599,7 +3617,7 @@
           <a:noFill/>
         </p:spPr>
         <p:txBody>
-          <a:bodyPr wrap="square" lIns="0" rIns="0" tIns="0" bIns="0" anchor="t">
+          <a:bodyPr wrap="square" lIns="0" tIns="0" rIns="0" bIns="0" anchor="t">
             <a:spAutoFit/>
           </a:bodyPr>
           <a:lstStyle/>
@@ -3662,6 +3680,7 @@
           <a:lstStyle/>
           <a:p>
             <a:pPr algn="ctr"/>
+            <a:endParaRPr/>
           </a:p>
         </p:txBody>
       </p:sp>
@@ -3706,6 +3725,7 @@
           <a:lstStyle/>
           <a:p>
             <a:pPr algn="ctr"/>
+            <a:endParaRPr/>
           </a:p>
         </p:txBody>
       </p:sp>
@@ -3717,8 +3737,8 @@
         </p:nvSpPr>
         <p:spPr>
           <a:xfrm>
-            <a:off x="1161288" y="4160520"/>
-            <a:ext cx="8531352" cy="1737360"/>
+            <a:off x="1161288" y="4797662"/>
+            <a:ext cx="8531352" cy="463075"/>
           </a:xfrm>
           <a:prstGeom prst="rect">
             <a:avLst/>
@@ -3726,7 +3746,7 @@
           <a:noFill/>
         </p:spPr>
         <p:txBody>
-          <a:bodyPr wrap="square" lIns="0" rIns="0" tIns="0" bIns="0" anchor="ctr">
+          <a:bodyPr wrap="square" lIns="0" tIns="0" rIns="0" bIns="0" anchor="ctr">
             <a:spAutoFit/>
           </a:bodyPr>
           <a:lstStyle/>
@@ -3743,23 +3763,16 @@
                 </a:solidFill>
                 <a:latin typeface="Petrona"/>
               </a:rPr>
-              <a:t>AI confidently invents facts — dates, numbers, citations, names.</a:t>
-            </a:r>
-          </a:p>
-          <a:p>
-            <a:pPr algn="l">
-              <a:lnSpc>
-                <a:spcPct val="125000"/>
-              </a:lnSpc>
-            </a:pPr>
-            <a:r>
-              <a:rPr sz="2600" b="1" i="0">
+              <a:t>Always </a:t>
+            </a:r>
+            <a:r>
+              <a:rPr sz="2600" b="1" i="0" dirty="0">
                 <a:solidFill>
                   <a:srgbClr val="030303"/>
                 </a:solidFill>
                 <a:latin typeface="Petrona"/>
               </a:rPr>
-              <a:t>Always review the output.</a:t>
+              <a:t>review the output.</a:t>
             </a:r>
           </a:p>
         </p:txBody>

</xml_diff>